<commit_message>
Decks: grammar highlighted in texts, auto retell after stories, read-not-listen wording
Co-Authored-By: Claude Opus 5.5 <noreply@anthropic.com>
Claude-Session: https://claude.ai/code/session_01WMhLn9wqKhsSQGNMWzVMPf
</commit_message>
<xml_diff>
--- a/materials/A2/A2_2C_One_dark_October_evening.pptx
+++ b/materials/A2/A2_2C_One_dark_October_evening.pptx
@@ -16491,11 +16491,8 @@
                 <a:ea typeface="Georgia" pitchFamily="34" charset="-122"/>
                 <a:cs typeface="Georgia" pitchFamily="34" charset="-120"/>
               </a:rPr>
-              <a:t>Hannah met Jamie last summer. It was Hannah's birthday and she and her friends went to a club. They wanted to dance, but they didn't like the music, so Hannah went to speak to the DJ. 'This music is awful,' she said. 'Could you play something else?' The DJ looked at her and said, 'Don't worry, I have the perfect song for you.'</a:t>
-            </a:r>
-            <a:endParaRPr lang="en-US" sz="1000" dirty="0"/>
-          </a:p>
-          <a:p>
+              <a:t>Hannah met Jamie last summer. It was Hannah's birthday and she and her friends went to a club. They wanted to dance, </a:t>
+            </a:r>
             <a:pPr indent="0" marL="0">
               <a:lnSpc>
                 <a:spcPct val="105000"/>
@@ -16506,15 +16503,15 @@
               <a:buNone/>
             </a:pPr>
             <a:r>
-              <a:rPr lang="en-US" sz="1000" dirty="0">
-                <a:solidFill>
-                  <a:srgbClr val="1B2559"/>
+              <a:rPr lang="en-US" sz="1000" b="1" u="sng" dirty="0">
+                <a:solidFill>
+                  <a:srgbClr val="7B5CD6"/>
                 </a:solidFill>
                 <a:latin typeface="Georgia" pitchFamily="34" charset="0"/>
                 <a:ea typeface="Georgia" pitchFamily="34" charset="-122"/>
                 <a:cs typeface="Georgia" pitchFamily="34" charset="-120"/>
               </a:rPr>
-              <a:t>'</a:t>
+              <a:t>but</a:t>
             </a:r>
             <a:pPr indent="0" marL="0">
               <a:lnSpc>
@@ -16526,6 +16523,89 @@
               <a:buNone/>
             </a:pPr>
             <a:r>
+              <a:rPr lang="en-US" sz="1000" dirty="0">
+                <a:solidFill>
+                  <a:srgbClr val="1B2559"/>
+                </a:solidFill>
+                <a:latin typeface="Georgia" pitchFamily="34" charset="0"/>
+                <a:ea typeface="Georgia" pitchFamily="34" charset="-122"/>
+                <a:cs typeface="Georgia" pitchFamily="34" charset="-120"/>
+              </a:rPr>
+              <a:t> they didn't like the music, </a:t>
+            </a:r>
+            <a:pPr indent="0" marL="0">
+              <a:lnSpc>
+                <a:spcPct val="105000"/>
+              </a:lnSpc>
+              <a:spcAft>
+                <a:spcPts val="700"/>
+              </a:spcAft>
+              <a:buNone/>
+            </a:pPr>
+            <a:r>
+              <a:rPr lang="en-US" sz="1000" b="1" u="sng" dirty="0">
+                <a:solidFill>
+                  <a:srgbClr val="7B5CD6"/>
+                </a:solidFill>
+                <a:latin typeface="Georgia" pitchFamily="34" charset="0"/>
+                <a:ea typeface="Georgia" pitchFamily="34" charset="-122"/>
+                <a:cs typeface="Georgia" pitchFamily="34" charset="-120"/>
+              </a:rPr>
+              <a:t>so</a:t>
+            </a:r>
+            <a:pPr indent="0" marL="0">
+              <a:lnSpc>
+                <a:spcPct val="105000"/>
+              </a:lnSpc>
+              <a:spcAft>
+                <a:spcPts val="700"/>
+              </a:spcAft>
+              <a:buNone/>
+            </a:pPr>
+            <a:r>
+              <a:rPr lang="en-US" sz="1000" dirty="0">
+                <a:solidFill>
+                  <a:srgbClr val="1B2559"/>
+                </a:solidFill>
+                <a:latin typeface="Georgia" pitchFamily="34" charset="0"/>
+                <a:ea typeface="Georgia" pitchFamily="34" charset="-122"/>
+                <a:cs typeface="Georgia" pitchFamily="34" charset="-120"/>
+              </a:rPr>
+              <a:t> Hannah went to speak to the DJ. 'This music is awful,' she said. 'Could you play something else?' The DJ looked at her and said, 'Don't worry, I have the perfect song for you.'</a:t>
+            </a:r>
+            <a:endParaRPr lang="en-US" sz="1000" dirty="0"/>
+          </a:p>
+          <a:p>
+            <a:pPr indent="0" marL="0">
+              <a:lnSpc>
+                <a:spcPct val="105000"/>
+              </a:lnSpc>
+              <a:spcAft>
+                <a:spcPts val="700"/>
+              </a:spcAft>
+              <a:buNone/>
+            </a:pPr>
+            <a:r>
+              <a:rPr lang="en-US" sz="1000" dirty="0">
+                <a:solidFill>
+                  <a:srgbClr val="1B2559"/>
+                </a:solidFill>
+                <a:latin typeface="Georgia" pitchFamily="34" charset="0"/>
+                <a:ea typeface="Georgia" pitchFamily="34" charset="-122"/>
+                <a:cs typeface="Georgia" pitchFamily="34" charset="-120"/>
+              </a:rPr>
+              <a:t>'</a:t>
+            </a:r>
+            <a:pPr indent="0" marL="0">
+              <a:lnSpc>
+                <a:spcPct val="105000"/>
+              </a:lnSpc>
+              <a:spcAft>
+                <a:spcPts val="700"/>
+              </a:spcAft>
+              <a:buNone/>
+            </a:pPr>
+            <a:r>
               <a:rPr lang="en-US" sz="1000" b="1" dirty="0">
                 <a:solidFill>
                   <a:srgbClr val="7B5CD6"/>
@@ -16600,11 +16680,8 @@
                 <a:ea typeface="Georgia" pitchFamily="34" charset="-122"/>
                 <a:cs typeface="Georgia" pitchFamily="34" charset="-120"/>
               </a:rPr>
-              <a:t> Hannah and her friends left the club, the DJ was waiting for her at the door. 'Hi, I'm Jamie,' he said to Hannah. 'Can I see you again?' So Hannah gave him her phone number.</a:t>
-            </a:r>
-            <a:endParaRPr lang="en-US" sz="1000" dirty="0"/>
-          </a:p>
-          <a:p>
+              <a:t> Hannah and her friends left the club, the DJ was waiting for her at the door. 'Hi, I'm Jamie,' he said to Hannah. 'Can I see you again?' </a:t>
+            </a:r>
             <a:pPr indent="0" marL="0">
               <a:lnSpc>
                 <a:spcPct val="105000"/>
@@ -16615,15 +16692,15 @@
               <a:buNone/>
             </a:pPr>
             <a:r>
-              <a:rPr lang="en-US" sz="1000" b="1" dirty="0">
-                <a:solidFill>
-                  <a:srgbClr val="2EB872"/>
+              <a:rPr lang="en-US" sz="1000" b="1" u="sng" dirty="0">
+                <a:solidFill>
+                  <a:srgbClr val="7B5CD6"/>
                 </a:solidFill>
                 <a:latin typeface="Georgia" pitchFamily="34" charset="0"/>
                 <a:ea typeface="Georgia" pitchFamily="34" charset="-122"/>
                 <a:cs typeface="Georgia" pitchFamily="34" charset="-120"/>
               </a:rPr>
-              <a:t> (3) ________ </a:t>
+              <a:t>So</a:t>
             </a:r>
             <a:pPr indent="0" marL="0">
               <a:lnSpc>
@@ -16643,7 +16720,90 @@
                 <a:ea typeface="Georgia" pitchFamily="34" charset="-122"/>
                 <a:cs typeface="Georgia" pitchFamily="34" charset="-120"/>
               </a:rPr>
-              <a:t> Jamie phoned Hannah and invited her to dinner. He took her to a very romantic French restaurant and they talked all evening. Although the food wasn't very good, they had a wonderful time.</a:t>
+              <a:t> Hannah gave him her phone number.</a:t>
+            </a:r>
+            <a:endParaRPr lang="en-US" sz="1000" dirty="0"/>
+          </a:p>
+          <a:p>
+            <a:pPr indent="0" marL="0">
+              <a:lnSpc>
+                <a:spcPct val="105000"/>
+              </a:lnSpc>
+              <a:spcAft>
+                <a:spcPts val="700"/>
+              </a:spcAft>
+              <a:buNone/>
+            </a:pPr>
+            <a:r>
+              <a:rPr lang="en-US" sz="1000" b="1" dirty="0">
+                <a:solidFill>
+                  <a:srgbClr val="2EB872"/>
+                </a:solidFill>
+                <a:latin typeface="Georgia" pitchFamily="34" charset="0"/>
+                <a:ea typeface="Georgia" pitchFamily="34" charset="-122"/>
+                <a:cs typeface="Georgia" pitchFamily="34" charset="-120"/>
+              </a:rPr>
+              <a:t> (3) ________ </a:t>
+            </a:r>
+            <a:pPr indent="0" marL="0">
+              <a:lnSpc>
+                <a:spcPct val="105000"/>
+              </a:lnSpc>
+              <a:spcAft>
+                <a:spcPts val="700"/>
+              </a:spcAft>
+              <a:buNone/>
+            </a:pPr>
+            <a:r>
+              <a:rPr lang="en-US" sz="1000" dirty="0">
+                <a:solidFill>
+                  <a:srgbClr val="1B2559"/>
+                </a:solidFill>
+                <a:latin typeface="Georgia" pitchFamily="34" charset="0"/>
+                <a:ea typeface="Georgia" pitchFamily="34" charset="-122"/>
+                <a:cs typeface="Georgia" pitchFamily="34" charset="-120"/>
+              </a:rPr>
+              <a:t> Jamie phoned Hannah and invited her to dinner. He took her to a very romantic French restaurant and they talked all evening. </a:t>
+            </a:r>
+            <a:pPr indent="0" marL="0">
+              <a:lnSpc>
+                <a:spcPct val="105000"/>
+              </a:lnSpc>
+              <a:spcAft>
+                <a:spcPts val="700"/>
+              </a:spcAft>
+              <a:buNone/>
+            </a:pPr>
+            <a:r>
+              <a:rPr lang="en-US" sz="1000" b="1" u="sng" dirty="0">
+                <a:solidFill>
+                  <a:srgbClr val="7B5CD6"/>
+                </a:solidFill>
+                <a:latin typeface="Georgia" pitchFamily="34" charset="0"/>
+                <a:ea typeface="Georgia" pitchFamily="34" charset="-122"/>
+                <a:cs typeface="Georgia" pitchFamily="34" charset="-120"/>
+              </a:rPr>
+              <a:t>Although</a:t>
+            </a:r>
+            <a:pPr indent="0" marL="0">
+              <a:lnSpc>
+                <a:spcPct val="105000"/>
+              </a:lnSpc>
+              <a:spcAft>
+                <a:spcPts val="700"/>
+              </a:spcAft>
+              <a:buNone/>
+            </a:pPr>
+            <a:r>
+              <a:rPr lang="en-US" sz="1000" dirty="0">
+                <a:solidFill>
+                  <a:srgbClr val="1B2559"/>
+                </a:solidFill>
+                <a:latin typeface="Georgia" pitchFamily="34" charset="0"/>
+                <a:ea typeface="Georgia" pitchFamily="34" charset="-122"/>
+                <a:cs typeface="Georgia" pitchFamily="34" charset="-120"/>
+              </a:rPr>
+              <a:t> the food wasn't very good, they had a wonderful time.</a:t>
             </a:r>
             <a:endParaRPr lang="en-US" sz="1000" dirty="0"/>
           </a:p>
@@ -16713,11 +16873,8 @@
                 <a:ea typeface="Georgia" pitchFamily="34" charset="-122"/>
                 <a:cs typeface="Georgia" pitchFamily="34" charset="-120"/>
               </a:rPr>
-              <a:t>Hannah met Jamie last summer. It was Hannah's birthday and she and her friends went to a club. They wanted to dance, but they didn't like the music, so Hannah went to speak to the DJ. 'This music is awful,' she said. 'Could you play something else?' The DJ looked at her and said, 'Don't worry, I have the perfect song for you.'</a:t>
-            </a:r>
-            <a:endParaRPr lang="en-US" sz="1000" dirty="0"/>
-          </a:p>
-          <a:p>
+              <a:t>Hannah met Jamie last summer. It was Hannah's birthday and she and her friends went to a club. They wanted to dance, </a:t>
+            </a:r>
             <a:pPr indent="0" marL="0">
               <a:lnSpc>
                 <a:spcPct val="105000"/>
@@ -16728,15 +16885,15 @@
               <a:buNone/>
             </a:pPr>
             <a:r>
-              <a:rPr lang="en-US" sz="1000" dirty="0">
-                <a:solidFill>
-                  <a:srgbClr val="1B2559"/>
+              <a:rPr lang="en-US" sz="1000" b="1" u="sng" dirty="0">
+                <a:solidFill>
+                  <a:srgbClr val="7B5CD6"/>
                 </a:solidFill>
                 <a:latin typeface="Georgia" pitchFamily="34" charset="0"/>
                 <a:ea typeface="Georgia" pitchFamily="34" charset="-122"/>
                 <a:cs typeface="Georgia" pitchFamily="34" charset="-120"/>
               </a:rPr>
-              <a:t>'</a:t>
+              <a:t>but</a:t>
             </a:r>
             <a:pPr indent="0" marL="0">
               <a:lnSpc>
@@ -16748,6 +16905,89 @@
               <a:buNone/>
             </a:pPr>
             <a:r>
+              <a:rPr lang="en-US" sz="1000" dirty="0">
+                <a:solidFill>
+                  <a:srgbClr val="1B2559"/>
+                </a:solidFill>
+                <a:latin typeface="Georgia" pitchFamily="34" charset="0"/>
+                <a:ea typeface="Georgia" pitchFamily="34" charset="-122"/>
+                <a:cs typeface="Georgia" pitchFamily="34" charset="-120"/>
+              </a:rPr>
+              <a:t> they didn't like the music, </a:t>
+            </a:r>
+            <a:pPr indent="0" marL="0">
+              <a:lnSpc>
+                <a:spcPct val="105000"/>
+              </a:lnSpc>
+              <a:spcAft>
+                <a:spcPts val="700"/>
+              </a:spcAft>
+              <a:buNone/>
+            </a:pPr>
+            <a:r>
+              <a:rPr lang="en-US" sz="1000" b="1" u="sng" dirty="0">
+                <a:solidFill>
+                  <a:srgbClr val="7B5CD6"/>
+                </a:solidFill>
+                <a:latin typeface="Georgia" pitchFamily="34" charset="0"/>
+                <a:ea typeface="Georgia" pitchFamily="34" charset="-122"/>
+                <a:cs typeface="Georgia" pitchFamily="34" charset="-120"/>
+              </a:rPr>
+              <a:t>so</a:t>
+            </a:r>
+            <a:pPr indent="0" marL="0">
+              <a:lnSpc>
+                <a:spcPct val="105000"/>
+              </a:lnSpc>
+              <a:spcAft>
+                <a:spcPts val="700"/>
+              </a:spcAft>
+              <a:buNone/>
+            </a:pPr>
+            <a:r>
+              <a:rPr lang="en-US" sz="1000" dirty="0">
+                <a:solidFill>
+                  <a:srgbClr val="1B2559"/>
+                </a:solidFill>
+                <a:latin typeface="Georgia" pitchFamily="34" charset="0"/>
+                <a:ea typeface="Georgia" pitchFamily="34" charset="-122"/>
+                <a:cs typeface="Georgia" pitchFamily="34" charset="-120"/>
+              </a:rPr>
+              <a:t> Hannah went to speak to the DJ. 'This music is awful,' she said. 'Could you play something else?' The DJ looked at her and said, 'Don't worry, I have the perfect song for you.'</a:t>
+            </a:r>
+            <a:endParaRPr lang="en-US" sz="1000" dirty="0"/>
+          </a:p>
+          <a:p>
+            <a:pPr indent="0" marL="0">
+              <a:lnSpc>
+                <a:spcPct val="105000"/>
+              </a:lnSpc>
+              <a:spcAft>
+                <a:spcPts val="700"/>
+              </a:spcAft>
+              <a:buNone/>
+            </a:pPr>
+            <a:r>
+              <a:rPr lang="en-US" sz="1000" dirty="0">
+                <a:solidFill>
+                  <a:srgbClr val="1B2559"/>
+                </a:solidFill>
+                <a:latin typeface="Georgia" pitchFamily="34" charset="0"/>
+                <a:ea typeface="Georgia" pitchFamily="34" charset="-122"/>
+                <a:cs typeface="Georgia" pitchFamily="34" charset="-120"/>
+              </a:rPr>
+              <a:t>'</a:t>
+            </a:r>
+            <a:pPr indent="0" marL="0">
+              <a:lnSpc>
+                <a:spcPct val="105000"/>
+              </a:lnSpc>
+              <a:spcAft>
+                <a:spcPts val="700"/>
+              </a:spcAft>
+              <a:buNone/>
+            </a:pPr>
+            <a:r>
               <a:rPr lang="en-US" sz="1000" b="1" dirty="0">
                 <a:solidFill>
                   <a:srgbClr val="7B5CD6"/>
@@ -16825,11 +17065,8 @@
                 <a:ea typeface="Georgia" pitchFamily="34" charset="-122"/>
                 <a:cs typeface="Georgia" pitchFamily="34" charset="-120"/>
               </a:rPr>
-              <a:t> Hannah and her friends left the club, the DJ was waiting for her at the door. 'Hi, I'm Jamie,' he said to Hannah. 'Can I see you again?' So Hannah gave him her phone number.</a:t>
-            </a:r>
-            <a:endParaRPr lang="en-US" sz="1000" dirty="0"/>
-          </a:p>
-          <a:p>
+              <a:t> Hannah and her friends left the club, the DJ was waiting for her at the door. 'Hi, I'm Jamie,' he said to Hannah. 'Can I see you again?' </a:t>
+            </a:r>
             <a:pPr indent="0" marL="0">
               <a:lnSpc>
                 <a:spcPct val="105000"/>
@@ -16840,15 +17077,15 @@
               <a:buNone/>
             </a:pPr>
             <a:r>
-              <a:rPr lang="en-US" sz="1000" b="1" dirty="0">
-                <a:solidFill>
-                  <a:srgbClr val="2EB872"/>
+              <a:rPr lang="en-US" sz="1000" b="1" u="sng" dirty="0">
+                <a:solidFill>
+                  <a:srgbClr val="7B5CD6"/>
                 </a:solidFill>
                 <a:latin typeface="Georgia" pitchFamily="34" charset="0"/>
                 <a:ea typeface="Georgia" pitchFamily="34" charset="-122"/>
                 <a:cs typeface="Georgia" pitchFamily="34" charset="-120"/>
               </a:rPr>
-              <a:t> (3) ________ </a:t>
+              <a:t>So</a:t>
             </a:r>
             <a:pPr indent="0" marL="0">
               <a:lnSpc>
@@ -16868,7 +17105,90 @@
                 <a:ea typeface="Georgia" pitchFamily="34" charset="-122"/>
                 <a:cs typeface="Georgia" pitchFamily="34" charset="-120"/>
               </a:rPr>
-              <a:t> Jamie phoned Hannah and invited her to dinner. He took her to a very romantic French restaurant and they talked all evening. Although the food wasn't very good, they had a wonderful time.</a:t>
+              <a:t> Hannah gave him her phone number.</a:t>
+            </a:r>
+            <a:endParaRPr lang="en-US" sz="1000" dirty="0"/>
+          </a:p>
+          <a:p>
+            <a:pPr indent="0" marL="0">
+              <a:lnSpc>
+                <a:spcPct val="105000"/>
+              </a:lnSpc>
+              <a:spcAft>
+                <a:spcPts val="700"/>
+              </a:spcAft>
+              <a:buNone/>
+            </a:pPr>
+            <a:r>
+              <a:rPr lang="en-US" sz="1000" b="1" dirty="0">
+                <a:solidFill>
+                  <a:srgbClr val="2EB872"/>
+                </a:solidFill>
+                <a:latin typeface="Georgia" pitchFamily="34" charset="0"/>
+                <a:ea typeface="Georgia" pitchFamily="34" charset="-122"/>
+                <a:cs typeface="Georgia" pitchFamily="34" charset="-120"/>
+              </a:rPr>
+              <a:t> (3) ________ </a:t>
+            </a:r>
+            <a:pPr indent="0" marL="0">
+              <a:lnSpc>
+                <a:spcPct val="105000"/>
+              </a:lnSpc>
+              <a:spcAft>
+                <a:spcPts val="700"/>
+              </a:spcAft>
+              <a:buNone/>
+            </a:pPr>
+            <a:r>
+              <a:rPr lang="en-US" sz="1000" dirty="0">
+                <a:solidFill>
+                  <a:srgbClr val="1B2559"/>
+                </a:solidFill>
+                <a:latin typeface="Georgia" pitchFamily="34" charset="0"/>
+                <a:ea typeface="Georgia" pitchFamily="34" charset="-122"/>
+                <a:cs typeface="Georgia" pitchFamily="34" charset="-120"/>
+              </a:rPr>
+              <a:t> Jamie phoned Hannah and invited her to dinner. He took her to a very romantic French restaurant and they talked all evening. </a:t>
+            </a:r>
+            <a:pPr indent="0" marL="0">
+              <a:lnSpc>
+                <a:spcPct val="105000"/>
+              </a:lnSpc>
+              <a:spcAft>
+                <a:spcPts val="700"/>
+              </a:spcAft>
+              <a:buNone/>
+            </a:pPr>
+            <a:r>
+              <a:rPr lang="en-US" sz="1000" b="1" u="sng" dirty="0">
+                <a:solidFill>
+                  <a:srgbClr val="7B5CD6"/>
+                </a:solidFill>
+                <a:latin typeface="Georgia" pitchFamily="34" charset="0"/>
+                <a:ea typeface="Georgia" pitchFamily="34" charset="-122"/>
+                <a:cs typeface="Georgia" pitchFamily="34" charset="-120"/>
+              </a:rPr>
+              <a:t>Although</a:t>
+            </a:r>
+            <a:pPr indent="0" marL="0">
+              <a:lnSpc>
+                <a:spcPct val="105000"/>
+              </a:lnSpc>
+              <a:spcAft>
+                <a:spcPts val="700"/>
+              </a:spcAft>
+              <a:buNone/>
+            </a:pPr>
+            <a:r>
+              <a:rPr lang="en-US" sz="1000" dirty="0">
+                <a:solidFill>
+                  <a:srgbClr val="1B2559"/>
+                </a:solidFill>
+                <a:latin typeface="Georgia" pitchFamily="34" charset="0"/>
+                <a:ea typeface="Georgia" pitchFamily="34" charset="-122"/>
+                <a:cs typeface="Georgia" pitchFamily="34" charset="-120"/>
+              </a:rPr>
+              <a:t> the food wasn't very good, they had a wonderful time.</a:t>
             </a:r>
             <a:endParaRPr lang="en-US" sz="1000" dirty="0"/>
           </a:p>
@@ -16938,11 +17258,8 @@
                 <a:ea typeface="Georgia" pitchFamily="34" charset="-122"/>
                 <a:cs typeface="Georgia" pitchFamily="34" charset="-120"/>
               </a:rPr>
-              <a:t>Hannah met Jamie last summer. It was Hannah's birthday and she and her friends went to a club. They wanted to dance, but they didn't like the music, so Hannah went to speak to the DJ. 'This music is awful,' she said. 'Could you play something else?' The DJ looked at her and said, 'Don't worry, I have the perfect song for you.'</a:t>
-            </a:r>
-            <a:endParaRPr lang="en-US" sz="1000" dirty="0"/>
-          </a:p>
-          <a:p>
+              <a:t>Hannah met Jamie last summer. It was Hannah's birthday and she and her friends went to a club. They wanted to dance, </a:t>
+            </a:r>
             <a:pPr indent="0" marL="0">
               <a:lnSpc>
                 <a:spcPct val="105000"/>
@@ -16953,15 +17270,15 @@
               <a:buNone/>
             </a:pPr>
             <a:r>
-              <a:rPr lang="en-US" sz="1000" dirty="0">
-                <a:solidFill>
-                  <a:srgbClr val="1B2559"/>
+              <a:rPr lang="en-US" sz="1000" b="1" u="sng" dirty="0">
+                <a:solidFill>
+                  <a:srgbClr val="7B5CD6"/>
                 </a:solidFill>
                 <a:latin typeface="Georgia" pitchFamily="34" charset="0"/>
                 <a:ea typeface="Georgia" pitchFamily="34" charset="-122"/>
                 <a:cs typeface="Georgia" pitchFamily="34" charset="-120"/>
               </a:rPr>
-              <a:t>'</a:t>
+              <a:t>but</a:t>
             </a:r>
             <a:pPr indent="0" marL="0">
               <a:lnSpc>
@@ -16973,6 +17290,89 @@
               <a:buNone/>
             </a:pPr>
             <a:r>
+              <a:rPr lang="en-US" sz="1000" dirty="0">
+                <a:solidFill>
+                  <a:srgbClr val="1B2559"/>
+                </a:solidFill>
+                <a:latin typeface="Georgia" pitchFamily="34" charset="0"/>
+                <a:ea typeface="Georgia" pitchFamily="34" charset="-122"/>
+                <a:cs typeface="Georgia" pitchFamily="34" charset="-120"/>
+              </a:rPr>
+              <a:t> they didn't like the music, </a:t>
+            </a:r>
+            <a:pPr indent="0" marL="0">
+              <a:lnSpc>
+                <a:spcPct val="105000"/>
+              </a:lnSpc>
+              <a:spcAft>
+                <a:spcPts val="700"/>
+              </a:spcAft>
+              <a:buNone/>
+            </a:pPr>
+            <a:r>
+              <a:rPr lang="en-US" sz="1000" b="1" u="sng" dirty="0">
+                <a:solidFill>
+                  <a:srgbClr val="7B5CD6"/>
+                </a:solidFill>
+                <a:latin typeface="Georgia" pitchFamily="34" charset="0"/>
+                <a:ea typeface="Georgia" pitchFamily="34" charset="-122"/>
+                <a:cs typeface="Georgia" pitchFamily="34" charset="-120"/>
+              </a:rPr>
+              <a:t>so</a:t>
+            </a:r>
+            <a:pPr indent="0" marL="0">
+              <a:lnSpc>
+                <a:spcPct val="105000"/>
+              </a:lnSpc>
+              <a:spcAft>
+                <a:spcPts val="700"/>
+              </a:spcAft>
+              <a:buNone/>
+            </a:pPr>
+            <a:r>
+              <a:rPr lang="en-US" sz="1000" dirty="0">
+                <a:solidFill>
+                  <a:srgbClr val="1B2559"/>
+                </a:solidFill>
+                <a:latin typeface="Georgia" pitchFamily="34" charset="0"/>
+                <a:ea typeface="Georgia" pitchFamily="34" charset="-122"/>
+                <a:cs typeface="Georgia" pitchFamily="34" charset="-120"/>
+              </a:rPr>
+              <a:t> Hannah went to speak to the DJ. 'This music is awful,' she said. 'Could you play something else?' The DJ looked at her and said, 'Don't worry, I have the perfect song for you.'</a:t>
+            </a:r>
+            <a:endParaRPr lang="en-US" sz="1000" dirty="0"/>
+          </a:p>
+          <a:p>
+            <a:pPr indent="0" marL="0">
+              <a:lnSpc>
+                <a:spcPct val="105000"/>
+              </a:lnSpc>
+              <a:spcAft>
+                <a:spcPts val="700"/>
+              </a:spcAft>
+              <a:buNone/>
+            </a:pPr>
+            <a:r>
+              <a:rPr lang="en-US" sz="1000" dirty="0">
+                <a:solidFill>
+                  <a:srgbClr val="1B2559"/>
+                </a:solidFill>
+                <a:latin typeface="Georgia" pitchFamily="34" charset="0"/>
+                <a:ea typeface="Georgia" pitchFamily="34" charset="-122"/>
+                <a:cs typeface="Georgia" pitchFamily="34" charset="-120"/>
+              </a:rPr>
+              <a:t>'</a:t>
+            </a:r>
+            <a:pPr indent="0" marL="0">
+              <a:lnSpc>
+                <a:spcPct val="105000"/>
+              </a:lnSpc>
+              <a:spcAft>
+                <a:spcPts val="700"/>
+              </a:spcAft>
+              <a:buNone/>
+            </a:pPr>
+            <a:r>
               <a:rPr lang="en-US" sz="1000" b="1" dirty="0">
                 <a:solidFill>
                   <a:srgbClr val="7B5CD6"/>
@@ -17050,11 +17450,8 @@
                 <a:ea typeface="Georgia" pitchFamily="34" charset="-122"/>
                 <a:cs typeface="Georgia" pitchFamily="34" charset="-120"/>
               </a:rPr>
-              <a:t> Hannah and her friends left the club, the DJ was waiting for her at the door. 'Hi, I'm Jamie,' he said to Hannah. 'Can I see you again?' So Hannah gave him her phone number.</a:t>
-            </a:r>
-            <a:endParaRPr lang="en-US" sz="1000" dirty="0"/>
-          </a:p>
-          <a:p>
+              <a:t> Hannah and her friends left the club, the DJ was waiting for her at the door. 'Hi, I'm Jamie,' he said to Hannah. 'Can I see you again?' </a:t>
+            </a:r>
             <a:pPr indent="0" marL="0">
               <a:lnSpc>
                 <a:spcPct val="105000"/>
@@ -17065,6 +17462,49 @@
               <a:buNone/>
             </a:pPr>
             <a:r>
+              <a:rPr lang="en-US" sz="1000" b="1" u="sng" dirty="0">
+                <a:solidFill>
+                  <a:srgbClr val="7B5CD6"/>
+                </a:solidFill>
+                <a:latin typeface="Georgia" pitchFamily="34" charset="0"/>
+                <a:ea typeface="Georgia" pitchFamily="34" charset="-122"/>
+                <a:cs typeface="Georgia" pitchFamily="34" charset="-120"/>
+              </a:rPr>
+              <a:t>So</a:t>
+            </a:r>
+            <a:pPr indent="0" marL="0">
+              <a:lnSpc>
+                <a:spcPct val="105000"/>
+              </a:lnSpc>
+              <a:spcAft>
+                <a:spcPts val="700"/>
+              </a:spcAft>
+              <a:buNone/>
+            </a:pPr>
+            <a:r>
+              <a:rPr lang="en-US" sz="1000" dirty="0">
+                <a:solidFill>
+                  <a:srgbClr val="1B2559"/>
+                </a:solidFill>
+                <a:latin typeface="Georgia" pitchFamily="34" charset="0"/>
+                <a:ea typeface="Georgia" pitchFamily="34" charset="-122"/>
+                <a:cs typeface="Georgia" pitchFamily="34" charset="-120"/>
+              </a:rPr>
+              <a:t> Hannah gave him her phone number.</a:t>
+            </a:r>
+            <a:endParaRPr lang="en-US" sz="1000" dirty="0"/>
+          </a:p>
+          <a:p>
+            <a:pPr indent="0" marL="0">
+              <a:lnSpc>
+                <a:spcPct val="105000"/>
+              </a:lnSpc>
+              <a:spcAft>
+                <a:spcPts val="700"/>
+              </a:spcAft>
+              <a:buNone/>
+            </a:pPr>
+            <a:r>
               <a:rPr lang="en-US" sz="1000" b="1" dirty="0">
                 <a:solidFill>
                   <a:srgbClr val="1B2559"/>
@@ -17096,7 +17536,47 @@
                 <a:ea typeface="Georgia" pitchFamily="34" charset="-122"/>
                 <a:cs typeface="Georgia" pitchFamily="34" charset="-120"/>
               </a:rPr>
-              <a:t> Jamie phoned Hannah and invited her to dinner. He took her to a very romantic French restaurant and they talked all evening. Although the food wasn't very good, they had a wonderful time.</a:t>
+              <a:t> Jamie phoned Hannah and invited her to dinner. He took her to a very romantic French restaurant and they talked all evening. </a:t>
+            </a:r>
+            <a:pPr indent="0" marL="0">
+              <a:lnSpc>
+                <a:spcPct val="105000"/>
+              </a:lnSpc>
+              <a:spcAft>
+                <a:spcPts val="700"/>
+              </a:spcAft>
+              <a:buNone/>
+            </a:pPr>
+            <a:r>
+              <a:rPr lang="en-US" sz="1000" b="1" u="sng" dirty="0">
+                <a:solidFill>
+                  <a:srgbClr val="7B5CD6"/>
+                </a:solidFill>
+                <a:latin typeface="Georgia" pitchFamily="34" charset="0"/>
+                <a:ea typeface="Georgia" pitchFamily="34" charset="-122"/>
+                <a:cs typeface="Georgia" pitchFamily="34" charset="-120"/>
+              </a:rPr>
+              <a:t>Although</a:t>
+            </a:r>
+            <a:pPr indent="0" marL="0">
+              <a:lnSpc>
+                <a:spcPct val="105000"/>
+              </a:lnSpc>
+              <a:spcAft>
+                <a:spcPts val="700"/>
+              </a:spcAft>
+              <a:buNone/>
+            </a:pPr>
+            <a:r>
+              <a:rPr lang="en-US" sz="1000" dirty="0">
+                <a:solidFill>
+                  <a:srgbClr val="1B2559"/>
+                </a:solidFill>
+                <a:latin typeface="Georgia" pitchFamily="34" charset="0"/>
+                <a:ea typeface="Georgia" pitchFamily="34" charset="-122"/>
+                <a:cs typeface="Georgia" pitchFamily="34" charset="-120"/>
+              </a:rPr>
+              <a:t> the food wasn't very good, they had a wonderful time.</a:t>
             </a:r>
             <a:endParaRPr lang="en-US" sz="1000" dirty="0"/>
           </a:p>
@@ -18135,7 +18615,7 @@
                 <a:ea typeface="Georgia" pitchFamily="34" charset="-122"/>
                 <a:cs typeface="Georgia" pitchFamily="34" charset="-120"/>
               </a:rPr>
-              <a:t>At 5.25 she was driving along the high street. She was going very fast because she was in a hurry. </a:t>
+              <a:t>At 5.25 she was driving along the high street. She was going very fast </a:t>
             </a:r>
             <a:pPr indent="0" marL="0">
               <a:lnSpc>
@@ -18147,15 +18627,15 @@
               <a:buNone/>
             </a:pPr>
             <a:r>
-              <a:rPr lang="en-US" sz="1200" b="1" dirty="0">
-                <a:solidFill>
-                  <a:srgbClr val="2EB872"/>
+              <a:rPr lang="en-US" sz="1200" b="1" u="sng" dirty="0">
+                <a:solidFill>
+                  <a:srgbClr val="7B5CD6"/>
                 </a:solidFill>
                 <a:latin typeface="Georgia" pitchFamily="34" charset="0"/>
                 <a:ea typeface="Georgia" pitchFamily="34" charset="-122"/>
                 <a:cs typeface="Georgia" pitchFamily="34" charset="-120"/>
               </a:rPr>
-              <a:t> (6) ________ </a:t>
+              <a:t>because</a:t>
             </a:r>
             <a:pPr indent="0" marL="0">
               <a:lnSpc>
@@ -18175,7 +18655,127 @@
                 <a:ea typeface="Georgia" pitchFamily="34" charset="-122"/>
                 <a:cs typeface="Georgia" pitchFamily="34" charset="-120"/>
               </a:rPr>
-              <a:t>, a man ran across the road. He was wearing a dark coat, so Hannah didn't see him at first. Quickly, she put her foot on the brake…</a:t>
+              <a:t> she was in a hurry. </a:t>
+            </a:r>
+            <a:pPr indent="0" marL="0">
+              <a:lnSpc>
+                <a:spcPct val="105000"/>
+              </a:lnSpc>
+              <a:spcAft>
+                <a:spcPts val="700"/>
+              </a:spcAft>
+              <a:buNone/>
+            </a:pPr>
+            <a:r>
+              <a:rPr lang="en-US" sz="1200" b="1" dirty="0">
+                <a:solidFill>
+                  <a:srgbClr val="2EB872"/>
+                </a:solidFill>
+                <a:latin typeface="Georgia" pitchFamily="34" charset="0"/>
+                <a:ea typeface="Georgia" pitchFamily="34" charset="-122"/>
+                <a:cs typeface="Georgia" pitchFamily="34" charset="-120"/>
+              </a:rPr>
+              <a:t> (6) ________ </a:t>
+            </a:r>
+            <a:pPr indent="0" marL="0">
+              <a:lnSpc>
+                <a:spcPct val="105000"/>
+              </a:lnSpc>
+              <a:spcAft>
+                <a:spcPts val="700"/>
+              </a:spcAft>
+              <a:buNone/>
+            </a:pPr>
+            <a:r>
+              <a:rPr lang="en-US" sz="1200" dirty="0">
+                <a:solidFill>
+                  <a:srgbClr val="1B2559"/>
+                </a:solidFill>
+                <a:latin typeface="Georgia" pitchFamily="34" charset="0"/>
+                <a:ea typeface="Georgia" pitchFamily="34" charset="-122"/>
+                <a:cs typeface="Georgia" pitchFamily="34" charset="-120"/>
+              </a:rPr>
+              <a:t>, a man ran across the road. He was wearing a dark coat, </a:t>
+            </a:r>
+            <a:pPr indent="0" marL="0">
+              <a:lnSpc>
+                <a:spcPct val="105000"/>
+              </a:lnSpc>
+              <a:spcAft>
+                <a:spcPts val="700"/>
+              </a:spcAft>
+              <a:buNone/>
+            </a:pPr>
+            <a:r>
+              <a:rPr lang="en-US" sz="1200" b="1" u="sng" dirty="0">
+                <a:solidFill>
+                  <a:srgbClr val="7B5CD6"/>
+                </a:solidFill>
+                <a:latin typeface="Georgia" pitchFamily="34" charset="0"/>
+                <a:ea typeface="Georgia" pitchFamily="34" charset="-122"/>
+                <a:cs typeface="Georgia" pitchFamily="34" charset="-120"/>
+              </a:rPr>
+              <a:t>so</a:t>
+            </a:r>
+            <a:pPr indent="0" marL="0">
+              <a:lnSpc>
+                <a:spcPct val="105000"/>
+              </a:lnSpc>
+              <a:spcAft>
+                <a:spcPts val="700"/>
+              </a:spcAft>
+              <a:buNone/>
+            </a:pPr>
+            <a:r>
+              <a:rPr lang="en-US" sz="1200" dirty="0">
+                <a:solidFill>
+                  <a:srgbClr val="1B2559"/>
+                </a:solidFill>
+                <a:latin typeface="Georgia" pitchFamily="34" charset="0"/>
+                <a:ea typeface="Georgia" pitchFamily="34" charset="-122"/>
+                <a:cs typeface="Georgia" pitchFamily="34" charset="-120"/>
+              </a:rPr>
+              <a:t> Hannah didn't see him at first. </a:t>
+            </a:r>
+            <a:pPr indent="0" marL="0">
+              <a:lnSpc>
+                <a:spcPct val="105000"/>
+              </a:lnSpc>
+              <a:spcAft>
+                <a:spcPts val="700"/>
+              </a:spcAft>
+              <a:buNone/>
+            </a:pPr>
+            <a:r>
+              <a:rPr lang="en-US" sz="1200" b="1" u="sng" dirty="0">
+                <a:solidFill>
+                  <a:srgbClr val="7B5CD6"/>
+                </a:solidFill>
+                <a:latin typeface="Georgia" pitchFamily="34" charset="0"/>
+                <a:ea typeface="Georgia" pitchFamily="34" charset="-122"/>
+                <a:cs typeface="Georgia" pitchFamily="34" charset="-120"/>
+              </a:rPr>
+              <a:t>Quickly</a:t>
+            </a:r>
+            <a:pPr indent="0" marL="0">
+              <a:lnSpc>
+                <a:spcPct val="105000"/>
+              </a:lnSpc>
+              <a:spcAft>
+                <a:spcPts val="700"/>
+              </a:spcAft>
+              <a:buNone/>
+            </a:pPr>
+            <a:r>
+              <a:rPr lang="en-US" sz="1200" dirty="0">
+                <a:solidFill>
+                  <a:srgbClr val="1B2559"/>
+                </a:solidFill>
+                <a:latin typeface="Georgia" pitchFamily="34" charset="0"/>
+                <a:ea typeface="Georgia" pitchFamily="34" charset="-122"/>
+                <a:cs typeface="Georgia" pitchFamily="34" charset="-120"/>
+              </a:rPr>
+              <a:t>, she put her foot on the brake…</a:t>
             </a:r>
             <a:endParaRPr lang="en-US" sz="1200" dirty="0"/>
           </a:p>
@@ -18334,7 +18934,7 @@
                 <a:ea typeface="Georgia" pitchFamily="34" charset="-122"/>
                 <a:cs typeface="Georgia" pitchFamily="34" charset="-120"/>
               </a:rPr>
-              <a:t>At 5.25 she was driving along the high street. She was going very fast because she was in a hurry. </a:t>
+              <a:t>At 5.25 she was driving along the high street. She was going very fast </a:t>
             </a:r>
             <a:pPr indent="0" marL="0">
               <a:lnSpc>
@@ -18346,15 +18946,15 @@
               <a:buNone/>
             </a:pPr>
             <a:r>
-              <a:rPr lang="en-US" sz="1200" b="1" dirty="0">
-                <a:solidFill>
-                  <a:srgbClr val="2EB872"/>
+              <a:rPr lang="en-US" sz="1200" b="1" u="sng" dirty="0">
+                <a:solidFill>
+                  <a:srgbClr val="7B5CD6"/>
                 </a:solidFill>
                 <a:latin typeface="Georgia" pitchFamily="34" charset="0"/>
                 <a:ea typeface="Georgia" pitchFamily="34" charset="-122"/>
                 <a:cs typeface="Georgia" pitchFamily="34" charset="-120"/>
               </a:rPr>
-              <a:t> (6) ________ </a:t>
+              <a:t>because</a:t>
             </a:r>
             <a:pPr indent="0" marL="0">
               <a:lnSpc>
@@ -18374,7 +18974,127 @@
                 <a:ea typeface="Georgia" pitchFamily="34" charset="-122"/>
                 <a:cs typeface="Georgia" pitchFamily="34" charset="-120"/>
               </a:rPr>
-              <a:t>, a man ran across the road. He was wearing a dark coat, so Hannah didn't see him at first. Quickly, she put her foot on the brake…</a:t>
+              <a:t> she was in a hurry. </a:t>
+            </a:r>
+            <a:pPr indent="0" marL="0">
+              <a:lnSpc>
+                <a:spcPct val="105000"/>
+              </a:lnSpc>
+              <a:spcAft>
+                <a:spcPts val="700"/>
+              </a:spcAft>
+              <a:buNone/>
+            </a:pPr>
+            <a:r>
+              <a:rPr lang="en-US" sz="1200" b="1" dirty="0">
+                <a:solidFill>
+                  <a:srgbClr val="2EB872"/>
+                </a:solidFill>
+                <a:latin typeface="Georgia" pitchFamily="34" charset="0"/>
+                <a:ea typeface="Georgia" pitchFamily="34" charset="-122"/>
+                <a:cs typeface="Georgia" pitchFamily="34" charset="-120"/>
+              </a:rPr>
+              <a:t> (6) ________ </a:t>
+            </a:r>
+            <a:pPr indent="0" marL="0">
+              <a:lnSpc>
+                <a:spcPct val="105000"/>
+              </a:lnSpc>
+              <a:spcAft>
+                <a:spcPts val="700"/>
+              </a:spcAft>
+              <a:buNone/>
+            </a:pPr>
+            <a:r>
+              <a:rPr lang="en-US" sz="1200" dirty="0">
+                <a:solidFill>
+                  <a:srgbClr val="1B2559"/>
+                </a:solidFill>
+                <a:latin typeface="Georgia" pitchFamily="34" charset="0"/>
+                <a:ea typeface="Georgia" pitchFamily="34" charset="-122"/>
+                <a:cs typeface="Georgia" pitchFamily="34" charset="-120"/>
+              </a:rPr>
+              <a:t>, a man ran across the road. He was wearing a dark coat, </a:t>
+            </a:r>
+            <a:pPr indent="0" marL="0">
+              <a:lnSpc>
+                <a:spcPct val="105000"/>
+              </a:lnSpc>
+              <a:spcAft>
+                <a:spcPts val="700"/>
+              </a:spcAft>
+              <a:buNone/>
+            </a:pPr>
+            <a:r>
+              <a:rPr lang="en-US" sz="1200" b="1" u="sng" dirty="0">
+                <a:solidFill>
+                  <a:srgbClr val="7B5CD6"/>
+                </a:solidFill>
+                <a:latin typeface="Georgia" pitchFamily="34" charset="0"/>
+                <a:ea typeface="Georgia" pitchFamily="34" charset="-122"/>
+                <a:cs typeface="Georgia" pitchFamily="34" charset="-120"/>
+              </a:rPr>
+              <a:t>so</a:t>
+            </a:r>
+            <a:pPr indent="0" marL="0">
+              <a:lnSpc>
+                <a:spcPct val="105000"/>
+              </a:lnSpc>
+              <a:spcAft>
+                <a:spcPts val="700"/>
+              </a:spcAft>
+              <a:buNone/>
+            </a:pPr>
+            <a:r>
+              <a:rPr lang="en-US" sz="1200" dirty="0">
+                <a:solidFill>
+                  <a:srgbClr val="1B2559"/>
+                </a:solidFill>
+                <a:latin typeface="Georgia" pitchFamily="34" charset="0"/>
+                <a:ea typeface="Georgia" pitchFamily="34" charset="-122"/>
+                <a:cs typeface="Georgia" pitchFamily="34" charset="-120"/>
+              </a:rPr>
+              <a:t> Hannah didn't see him at first. </a:t>
+            </a:r>
+            <a:pPr indent="0" marL="0">
+              <a:lnSpc>
+                <a:spcPct val="105000"/>
+              </a:lnSpc>
+              <a:spcAft>
+                <a:spcPts val="700"/>
+              </a:spcAft>
+              <a:buNone/>
+            </a:pPr>
+            <a:r>
+              <a:rPr lang="en-US" sz="1200" b="1" u="sng" dirty="0">
+                <a:solidFill>
+                  <a:srgbClr val="7B5CD6"/>
+                </a:solidFill>
+                <a:latin typeface="Georgia" pitchFamily="34" charset="0"/>
+                <a:ea typeface="Georgia" pitchFamily="34" charset="-122"/>
+                <a:cs typeface="Georgia" pitchFamily="34" charset="-120"/>
+              </a:rPr>
+              <a:t>Quickly</a:t>
+            </a:r>
+            <a:pPr indent="0" marL="0">
+              <a:lnSpc>
+                <a:spcPct val="105000"/>
+              </a:lnSpc>
+              <a:spcAft>
+                <a:spcPts val="700"/>
+              </a:spcAft>
+              <a:buNone/>
+            </a:pPr>
+            <a:r>
+              <a:rPr lang="en-US" sz="1200" dirty="0">
+                <a:solidFill>
+                  <a:srgbClr val="1B2559"/>
+                </a:solidFill>
+                <a:latin typeface="Georgia" pitchFamily="34" charset="0"/>
+                <a:ea typeface="Georgia" pitchFamily="34" charset="-122"/>
+                <a:cs typeface="Georgia" pitchFamily="34" charset="-120"/>
+              </a:rPr>
+              <a:t>, she put her foot on the brake…</a:t>
             </a:r>
             <a:endParaRPr lang="en-US" sz="1200" dirty="0"/>
           </a:p>
@@ -18536,7 +19256,7 @@
                 <a:ea typeface="Georgia" pitchFamily="34" charset="-122"/>
                 <a:cs typeface="Georgia" pitchFamily="34" charset="-120"/>
               </a:rPr>
-              <a:t>At 5.25 she was driving along the high street. She was going very fast because she was in a hurry. </a:t>
+              <a:t>At 5.25 she was driving along the high street. She was going very fast </a:t>
             </a:r>
             <a:pPr indent="0" marL="0">
               <a:lnSpc>
@@ -18548,15 +19268,15 @@
               <a:buNone/>
             </a:pPr>
             <a:r>
-              <a:rPr lang="en-US" sz="1200" b="1" dirty="0">
-                <a:solidFill>
-                  <a:srgbClr val="2EB872"/>
+              <a:rPr lang="en-US" sz="1200" b="1" u="sng" dirty="0">
+                <a:solidFill>
+                  <a:srgbClr val="7B5CD6"/>
                 </a:solidFill>
                 <a:latin typeface="Georgia" pitchFamily="34" charset="0"/>
                 <a:ea typeface="Georgia" pitchFamily="34" charset="-122"/>
                 <a:cs typeface="Georgia" pitchFamily="34" charset="-120"/>
               </a:rPr>
-              <a:t> (6) ________ </a:t>
+              <a:t>because</a:t>
             </a:r>
             <a:pPr indent="0" marL="0">
               <a:lnSpc>
@@ -18576,7 +19296,127 @@
                 <a:ea typeface="Georgia" pitchFamily="34" charset="-122"/>
                 <a:cs typeface="Georgia" pitchFamily="34" charset="-120"/>
               </a:rPr>
-              <a:t>, a man ran across the road. He was wearing a dark coat, so Hannah didn't see him at first. Quickly, she put her foot on the brake…</a:t>
+              <a:t> she was in a hurry. </a:t>
+            </a:r>
+            <a:pPr indent="0" marL="0">
+              <a:lnSpc>
+                <a:spcPct val="105000"/>
+              </a:lnSpc>
+              <a:spcAft>
+                <a:spcPts val="700"/>
+              </a:spcAft>
+              <a:buNone/>
+            </a:pPr>
+            <a:r>
+              <a:rPr lang="en-US" sz="1200" b="1" dirty="0">
+                <a:solidFill>
+                  <a:srgbClr val="2EB872"/>
+                </a:solidFill>
+                <a:latin typeface="Georgia" pitchFamily="34" charset="0"/>
+                <a:ea typeface="Georgia" pitchFamily="34" charset="-122"/>
+                <a:cs typeface="Georgia" pitchFamily="34" charset="-120"/>
+              </a:rPr>
+              <a:t> (6) ________ </a:t>
+            </a:r>
+            <a:pPr indent="0" marL="0">
+              <a:lnSpc>
+                <a:spcPct val="105000"/>
+              </a:lnSpc>
+              <a:spcAft>
+                <a:spcPts val="700"/>
+              </a:spcAft>
+              <a:buNone/>
+            </a:pPr>
+            <a:r>
+              <a:rPr lang="en-US" sz="1200" dirty="0">
+                <a:solidFill>
+                  <a:srgbClr val="1B2559"/>
+                </a:solidFill>
+                <a:latin typeface="Georgia" pitchFamily="34" charset="0"/>
+                <a:ea typeface="Georgia" pitchFamily="34" charset="-122"/>
+                <a:cs typeface="Georgia" pitchFamily="34" charset="-120"/>
+              </a:rPr>
+              <a:t>, a man ran across the road. He was wearing a dark coat, </a:t>
+            </a:r>
+            <a:pPr indent="0" marL="0">
+              <a:lnSpc>
+                <a:spcPct val="105000"/>
+              </a:lnSpc>
+              <a:spcAft>
+                <a:spcPts val="700"/>
+              </a:spcAft>
+              <a:buNone/>
+            </a:pPr>
+            <a:r>
+              <a:rPr lang="en-US" sz="1200" b="1" u="sng" dirty="0">
+                <a:solidFill>
+                  <a:srgbClr val="7B5CD6"/>
+                </a:solidFill>
+                <a:latin typeface="Georgia" pitchFamily="34" charset="0"/>
+                <a:ea typeface="Georgia" pitchFamily="34" charset="-122"/>
+                <a:cs typeface="Georgia" pitchFamily="34" charset="-120"/>
+              </a:rPr>
+              <a:t>so</a:t>
+            </a:r>
+            <a:pPr indent="0" marL="0">
+              <a:lnSpc>
+                <a:spcPct val="105000"/>
+              </a:lnSpc>
+              <a:spcAft>
+                <a:spcPts val="700"/>
+              </a:spcAft>
+              <a:buNone/>
+            </a:pPr>
+            <a:r>
+              <a:rPr lang="en-US" sz="1200" dirty="0">
+                <a:solidFill>
+                  <a:srgbClr val="1B2559"/>
+                </a:solidFill>
+                <a:latin typeface="Georgia" pitchFamily="34" charset="0"/>
+                <a:ea typeface="Georgia" pitchFamily="34" charset="-122"/>
+                <a:cs typeface="Georgia" pitchFamily="34" charset="-120"/>
+              </a:rPr>
+              <a:t> Hannah didn't see him at first. </a:t>
+            </a:r>
+            <a:pPr indent="0" marL="0">
+              <a:lnSpc>
+                <a:spcPct val="105000"/>
+              </a:lnSpc>
+              <a:spcAft>
+                <a:spcPts val="700"/>
+              </a:spcAft>
+              <a:buNone/>
+            </a:pPr>
+            <a:r>
+              <a:rPr lang="en-US" sz="1200" b="1" u="sng" dirty="0">
+                <a:solidFill>
+                  <a:srgbClr val="7B5CD6"/>
+                </a:solidFill>
+                <a:latin typeface="Georgia" pitchFamily="34" charset="0"/>
+                <a:ea typeface="Georgia" pitchFamily="34" charset="-122"/>
+                <a:cs typeface="Georgia" pitchFamily="34" charset="-120"/>
+              </a:rPr>
+              <a:t>Quickly</a:t>
+            </a:r>
+            <a:pPr indent="0" marL="0">
+              <a:lnSpc>
+                <a:spcPct val="105000"/>
+              </a:lnSpc>
+              <a:spcAft>
+                <a:spcPts val="700"/>
+              </a:spcAft>
+              <a:buNone/>
+            </a:pPr>
+            <a:r>
+              <a:rPr lang="en-US" sz="1200" dirty="0">
+                <a:solidFill>
+                  <a:srgbClr val="1B2559"/>
+                </a:solidFill>
+                <a:latin typeface="Georgia" pitchFamily="34" charset="0"/>
+                <a:ea typeface="Georgia" pitchFamily="34" charset="-122"/>
+                <a:cs typeface="Georgia" pitchFamily="34" charset="-120"/>
+              </a:rPr>
+              <a:t>, she put her foot on the brake…</a:t>
             </a:r>
             <a:endParaRPr lang="en-US" sz="1200" dirty="0"/>
           </a:p>
@@ -18738,7 +19578,7 @@
                 <a:ea typeface="Georgia" pitchFamily="34" charset="-122"/>
                 <a:cs typeface="Georgia" pitchFamily="34" charset="-120"/>
               </a:rPr>
-              <a:t>At 5.25 she was driving along the high street. She was going very fast because she was in a hurry. </a:t>
+              <a:t>At 5.25 she was driving along the high street. She was going very fast </a:t>
             </a:r>
             <a:pPr indent="0" marL="0">
               <a:lnSpc>
@@ -18750,6 +19590,46 @@
               <a:buNone/>
             </a:pPr>
             <a:r>
+              <a:rPr lang="en-US" sz="1200" b="1" u="sng" dirty="0">
+                <a:solidFill>
+                  <a:srgbClr val="7B5CD6"/>
+                </a:solidFill>
+                <a:latin typeface="Georgia" pitchFamily="34" charset="0"/>
+                <a:ea typeface="Georgia" pitchFamily="34" charset="-122"/>
+                <a:cs typeface="Georgia" pitchFamily="34" charset="-120"/>
+              </a:rPr>
+              <a:t>because</a:t>
+            </a:r>
+            <a:pPr indent="0" marL="0">
+              <a:lnSpc>
+                <a:spcPct val="105000"/>
+              </a:lnSpc>
+              <a:spcAft>
+                <a:spcPts val="700"/>
+              </a:spcAft>
+              <a:buNone/>
+            </a:pPr>
+            <a:r>
+              <a:rPr lang="en-US" sz="1200" dirty="0">
+                <a:solidFill>
+                  <a:srgbClr val="1B2559"/>
+                </a:solidFill>
+                <a:latin typeface="Georgia" pitchFamily="34" charset="0"/>
+                <a:ea typeface="Georgia" pitchFamily="34" charset="-122"/>
+                <a:cs typeface="Georgia" pitchFamily="34" charset="-120"/>
+              </a:rPr>
+              <a:t> she was in a hurry. </a:t>
+            </a:r>
+            <a:pPr indent="0" marL="0">
+              <a:lnSpc>
+                <a:spcPct val="105000"/>
+              </a:lnSpc>
+              <a:spcAft>
+                <a:spcPts val="700"/>
+              </a:spcAft>
+              <a:buNone/>
+            </a:pPr>
+            <a:r>
               <a:rPr lang="en-US" sz="1200" b="1" dirty="0">
                 <a:solidFill>
                   <a:srgbClr val="1B2559"/>
@@ -18781,7 +19661,87 @@
                 <a:ea typeface="Georgia" pitchFamily="34" charset="-122"/>
                 <a:cs typeface="Georgia" pitchFamily="34" charset="-120"/>
               </a:rPr>
-              <a:t>, a man ran across the road. He was wearing a dark coat, so Hannah didn't see him at first. Quickly, she put her foot on the brake…</a:t>
+              <a:t>, a man ran across the road. He was wearing a dark coat, </a:t>
+            </a:r>
+            <a:pPr indent="0" marL="0">
+              <a:lnSpc>
+                <a:spcPct val="105000"/>
+              </a:lnSpc>
+              <a:spcAft>
+                <a:spcPts val="700"/>
+              </a:spcAft>
+              <a:buNone/>
+            </a:pPr>
+            <a:r>
+              <a:rPr lang="en-US" sz="1200" b="1" u="sng" dirty="0">
+                <a:solidFill>
+                  <a:srgbClr val="7B5CD6"/>
+                </a:solidFill>
+                <a:latin typeface="Georgia" pitchFamily="34" charset="0"/>
+                <a:ea typeface="Georgia" pitchFamily="34" charset="-122"/>
+                <a:cs typeface="Georgia" pitchFamily="34" charset="-120"/>
+              </a:rPr>
+              <a:t>so</a:t>
+            </a:r>
+            <a:pPr indent="0" marL="0">
+              <a:lnSpc>
+                <a:spcPct val="105000"/>
+              </a:lnSpc>
+              <a:spcAft>
+                <a:spcPts val="700"/>
+              </a:spcAft>
+              <a:buNone/>
+            </a:pPr>
+            <a:r>
+              <a:rPr lang="en-US" sz="1200" dirty="0">
+                <a:solidFill>
+                  <a:srgbClr val="1B2559"/>
+                </a:solidFill>
+                <a:latin typeface="Georgia" pitchFamily="34" charset="0"/>
+                <a:ea typeface="Georgia" pitchFamily="34" charset="-122"/>
+                <a:cs typeface="Georgia" pitchFamily="34" charset="-120"/>
+              </a:rPr>
+              <a:t> Hannah didn't see him at first. </a:t>
+            </a:r>
+            <a:pPr indent="0" marL="0">
+              <a:lnSpc>
+                <a:spcPct val="105000"/>
+              </a:lnSpc>
+              <a:spcAft>
+                <a:spcPts val="700"/>
+              </a:spcAft>
+              <a:buNone/>
+            </a:pPr>
+            <a:r>
+              <a:rPr lang="en-US" sz="1200" b="1" u="sng" dirty="0">
+                <a:solidFill>
+                  <a:srgbClr val="7B5CD6"/>
+                </a:solidFill>
+                <a:latin typeface="Georgia" pitchFamily="34" charset="0"/>
+                <a:ea typeface="Georgia" pitchFamily="34" charset="-122"/>
+                <a:cs typeface="Georgia" pitchFamily="34" charset="-120"/>
+              </a:rPr>
+              <a:t>Quickly</a:t>
+            </a:r>
+            <a:pPr indent="0" marL="0">
+              <a:lnSpc>
+                <a:spcPct val="105000"/>
+              </a:lnSpc>
+              <a:spcAft>
+                <a:spcPts val="700"/>
+              </a:spcAft>
+              <a:buNone/>
+            </a:pPr>
+            <a:r>
+              <a:rPr lang="en-US" sz="1200" dirty="0">
+                <a:solidFill>
+                  <a:srgbClr val="1B2559"/>
+                </a:solidFill>
+                <a:latin typeface="Georgia" pitchFamily="34" charset="0"/>
+                <a:ea typeface="Georgia" pitchFamily="34" charset="-122"/>
+                <a:cs typeface="Georgia" pitchFamily="34" charset="-120"/>
+              </a:rPr>
+              <a:t>, she put her foot on the brake…</a:t>
             </a:r>
             <a:endParaRPr lang="en-US" sz="1200" dirty="0"/>
           </a:p>

</xml_diff>